<commit_message>
docs: replace GASH_Control_Pitch_Deck.pptx with updated 12-slide presentation content
</commit_message>
<xml_diff>
--- a/GASH_Control_Pitch_Deck.pptx
+++ b/GASH_Control_Pitch_Deck.pptx
@@ -6530,22 +6530,6 @@
             <a:br/>
             <a:r>
               <a:t>X-API-Key: forte-datathon-2026-key</a:t>
-            </a:r>
-          </a:p>
-          <a:p>
-            <a:pPr>
-              <a:spcBef>
-                <a:spcPts val="400"/>
-              </a:spcBef>
-              <a:defRPr sz="1100">
-                <a:solidFill>
-                  <a:srgbClr val="A8A6B3"/>
-                </a:solidFill>
-                <a:latin typeface="Arial"/>
-              </a:defRPr>
-            </a:pPr>
-            <a:r>
-              <a:t>Документация Swagger UI: /docs</a:t>
             </a:r>
           </a:p>
         </p:txBody>

</xml_diff>